<commit_message>
fix(3d): steady labels, drivable taxi, no ground flicker, visible wheels; fix(slides): undistorted photos
- labels: pulse animation no longer overrides the position transform (labels jumped
  to the corner every 1.2 s); update every frame; priority-based decluttering
- taxi: never trapped inside a building footprint; resets avoid footprints
- flicker: near plane follows altitude, ground layers ordered by polygon-offset units,
  road markings and window patterns fade with distance, shadow box snaps to texels
- smooth camera blend when switching drive/drone; drone rises behind the taxi
- ground layers lowered to a few cm so the taxi's wheels are no longer buried;
  grey tyres with hubcaps read on dark asphalt
- slides: crop photos from their real aspect ratio instead of stretching them

Co-Authored-By: Claude Opus 5.5 <noreply@anthropic.com>
Claude-Session: https://claude.ai/code/session_01UC8CCQNAnYx41QquN8Eiuo
</commit_message>
<xml_diff>
--- a/slides/AI-Golden-Century-Taipei.pptx
+++ b/slides/AI-Golden-Century-Taipei.pptx
@@ -122,19 +122,19 @@
   <p:extLst>
     <p:ext uri="{521415D9-36F7-43E2-AB2F-B90AF26B5E84}">
       <p14:sectionLst xmlns:p14="http://schemas.microsoft.com/office/powerpoint/2010/main">
-        <p14:section name="開場" id="{6de269b6-54ca-4a2f-b2fd-3197dc8ce3ce}">
+        <p14:section name="開場" id="{503b6eb5-544e-8b46-de41-89b67bb1ba86}">
           <p14:sldIdLst>
             <p14:sldId id="256"/>
           </p14:sldIdLst>
         </p14:section>
-        <p14:section name="願景" id="{483e6d69-2525-a95a-884f-fb23317a4f53}">
+        <p14:section name="願景" id="{79082691-a8ab-03a0-6611-36b1bb4bf04b}">
           <p14:sldIdLst>
             <p14:sldId id="257"/>
             <p14:sldId id="258"/>
             <p14:sldId id="259"/>
           </p14:sldIdLst>
         </p14:section>
-        <p14:section name="300公頃" id="{1c8eb359-5258-2150-092e-3af4714dbd79}">
+        <p14:section name="300公頃" id="{428206a2-1c46-9b7c-cad3-1345617114eb}">
           <p14:sldIdLst>
             <p14:sldId id="260"/>
             <p14:sldId id="261"/>
@@ -143,19 +143,19 @@
             <p14:sldId id="264"/>
           </p14:sldIdLst>
         </p14:section>
-        <p14:section name="交通" id="{1afb378a-2181-c058-3664-e89d225c066c}">
+        <p14:section name="交通" id="{3f129005-ea7c-aed6-99dc-6844b2c594a9}">
           <p14:sldIdLst>
             <p14:sldId id="265"/>
             <p14:sldId id="266"/>
           </p14:sldIdLst>
         </p14:section>
-        <p14:section name="大台北新矽谷" id="{56eb863b-9529-a41e-f138-4cf3b36c3472}">
+        <p14:section name="大台北新矽谷" id="{210cc855-5202-0621-96b8-5299723a1b82}">
           <p14:sldIdLst>
             <p14:sldId id="267"/>
             <p14:sldId id="268"/>
           </p14:sldIdLst>
         </p14:section>
-        <p14:section name="體驗與結語" id="{8c7b9326-1bc3-ae30-a45c-39e21fe2ad97}">
+        <p14:section name="體驗與結語" id="{8b11c183-9065-f648-9ce6-cf9fc324b253}">
           <p14:sldIdLst>
             <p14:sldId id="269"/>
             <p14:sldId id="270"/>
@@ -3331,7 +3331,7 @@
         </p:nvPicPr>
         <p:blipFill>
           <a:blip r:embed="rId1"/>
-          <a:srcRect l="0" r="0" t="0" b="0"/>
+          <a:srcRect l="10142" r="10142" t="0" b="0"/>
           <a:stretch/>
         </p:blipFill>
         <p:spPr>
@@ -5955,7 +5955,7 @@
         </p:nvPicPr>
         <p:blipFill>
           <a:blip r:embed="rId1"/>
-          <a:srcRect l="0" r="0" t="0" b="0"/>
+          <a:srcRect l="0" r="0" t="6422" b="25690"/>
           <a:stretch/>
         </p:blipFill>
         <p:spPr>
@@ -6014,7 +6014,7 @@
         </p:nvPicPr>
         <p:blipFill>
           <a:blip r:embed="rId2"/>
-          <a:srcRect l="0" r="0" t="0" b="0"/>
+          <a:srcRect l="6461" r="6461" t="0" b="0"/>
           <a:stretch/>
         </p:blipFill>
         <p:spPr>
@@ -7256,7 +7256,7 @@
         </p:nvPicPr>
         <p:blipFill>
           <a:blip r:embed="rId1"/>
-          <a:srcRect l="0" r="0" t="0" b="0"/>
+          <a:srcRect l="0" r="0" t="136" b="136"/>
           <a:stretch/>
         </p:blipFill>
         <p:spPr>
@@ -7490,7 +7490,7 @@
         </p:nvPicPr>
         <p:blipFill>
           <a:blip r:embed="rId1"/>
-          <a:srcRect l="0" r="0" t="0" b="0"/>
+          <a:srcRect l="0" r="0" t="2359" b="9438"/>
           <a:stretch/>
         </p:blipFill>
         <p:spPr>
@@ -7938,7 +7938,7 @@
         </p:nvPicPr>
         <p:blipFill>
           <a:blip r:embed="rId1"/>
-          <a:srcRect l="0" r="0" t="0" b="0"/>
+          <a:srcRect l="70" r="70" t="0" b="0"/>
           <a:stretch/>
         </p:blipFill>
         <p:spPr>
@@ -8899,7 +8899,7 @@
         </p:nvPicPr>
         <p:blipFill>
           <a:blip r:embed="rId1"/>
-          <a:srcRect l="0" r="0" t="0" b="0"/>
+          <a:srcRect l="0" r="0" t="109" b="437"/>
           <a:stretch/>
         </p:blipFill>
         <p:spPr>
@@ -10078,7 +10078,7 @@
         </p:nvPicPr>
         <p:blipFill>
           <a:blip r:embed="rId1"/>
-          <a:srcRect l="0" r="0" t="0" b="0"/>
+          <a:srcRect l="47" r="47" t="0" b="0"/>
           <a:stretch/>
         </p:blipFill>
         <p:spPr>
@@ -10101,7 +10101,7 @@
         </p:nvPicPr>
         <p:blipFill>
           <a:blip r:embed="rId2"/>
-          <a:srcRect l="0" r="0" t="0" b="0"/>
+          <a:srcRect l="47" r="47" t="0" b="0"/>
           <a:stretch/>
         </p:blipFill>
         <p:spPr>
@@ -10456,7 +10456,7 @@
         </p:nvPicPr>
         <p:blipFill>
           <a:blip r:embed="rId1"/>
-          <a:srcRect l="0" r="0" t="0" b="0"/>
+          <a:srcRect l="12500" r="12500" t="0" b="0"/>
           <a:stretch/>
         </p:blipFill>
         <p:spPr>
@@ -10839,7 +10839,7 @@
         </p:nvPicPr>
         <p:blipFill>
           <a:blip r:embed="rId1"/>
-          <a:srcRect l="0" r="0" t="0" b="0"/>
+          <a:srcRect l="12500" r="12500" t="0" b="0"/>
           <a:stretch/>
         </p:blipFill>
         <p:spPr>
@@ -11058,7 +11058,7 @@
         </p:nvPicPr>
         <p:blipFill>
           <a:blip r:embed="rId1"/>
-          <a:srcRect l="0" r="0" t="0" b="0"/>
+          <a:srcRect l="5649" r="5649" t="0" b="0"/>
           <a:stretch/>
         </p:blipFill>
         <p:spPr>
@@ -11081,7 +11081,7 @@
         </p:nvPicPr>
         <p:blipFill>
           <a:blip r:embed="rId2"/>
-          <a:srcRect l="0" r="0" t="0" b="0"/>
+          <a:srcRect l="5649" r="5649" t="0" b="0"/>
           <a:stretch/>
         </p:blipFill>
         <p:spPr>

</xml_diff>

<commit_message>
3D: fix black blocks when the 2033 transition starts; slides viewer artifact
- Roofs of the new homes started at zero height; three.js divides instanced
  normals by the squared scale, so they turned NaN and the bloom pass
  smeared them into large black rectangles. Keep every growing instance at
  a minimum thickness and clamp what enters the bloom pass.
- artifact_slides.html + build_slides(): a slide viewer artifact with every
  page, speaker notes, keyboard/swipe paging and the real PPTX/PDF files
- Deck QR code and link now point at the Claude Artifact copy of the site

Co-Authored-By: Claude Opus 5.5 <noreply@anthropic.com>
Claude-Session: https://claude.ai/code/session_01UC8CCQNAnYx41QquN8Eiuo
</commit_message>
<xml_diff>
--- a/slides/AI-Golden-Century-Taipei.pptx
+++ b/slides/AI-Golden-Century-Taipei.pptx
@@ -122,19 +122,19 @@
   <p:extLst>
     <p:ext uri="{521415D9-36F7-43E2-AB2F-B90AF26B5E84}">
       <p14:sectionLst xmlns:p14="http://schemas.microsoft.com/office/powerpoint/2010/main">
-        <p14:section name="開場" id="{503b6eb5-544e-8b46-de41-89b67bb1ba86}">
+        <p14:section name="開場" id="{aad36a92-4567-536f-9810-a32969ca7a51}">
           <p14:sldIdLst>
             <p14:sldId id="256"/>
           </p14:sldIdLst>
         </p14:section>
-        <p14:section name="願景" id="{79082691-a8ab-03a0-6611-36b1bb4bf04b}">
+        <p14:section name="願景" id="{ef959c64-0721-e910-bca6-475b7ff2a9f4}">
           <p14:sldIdLst>
             <p14:sldId id="257"/>
             <p14:sldId id="258"/>
             <p14:sldId id="259"/>
           </p14:sldIdLst>
         </p14:section>
-        <p14:section name="300公頃" id="{428206a2-1c46-9b7c-cad3-1345617114eb}">
+        <p14:section name="300公頃" id="{5d6ce175-a6c3-6755-8cdb-0cdacc174c9f}">
           <p14:sldIdLst>
             <p14:sldId id="260"/>
             <p14:sldId id="261"/>
@@ -143,19 +143,19 @@
             <p14:sldId id="264"/>
           </p14:sldIdLst>
         </p14:section>
-        <p14:section name="交通" id="{3f129005-ea7c-aed6-99dc-6844b2c594a9}">
+        <p14:section name="交通" id="{8ecfb4a0-56b7-0a76-3f5a-95ed55731658}">
           <p14:sldIdLst>
             <p14:sldId id="265"/>
             <p14:sldId id="266"/>
           </p14:sldIdLst>
         </p14:section>
-        <p14:section name="大台北新矽谷" id="{210cc855-5202-0621-96b8-5299723a1b82}">
+        <p14:section name="大台北新矽谷" id="{9a188189-4736-2817-f4e9-532448fb3a93}">
           <p14:sldIdLst>
             <p14:sldId id="267"/>
             <p14:sldId id="268"/>
           </p14:sldIdLst>
         </p14:section>
-        <p14:section name="體驗與結語" id="{8b11c183-9065-f648-9ce6-cf9fc324b253}">
+        <p14:section name="體驗與結語" id="{d77bfd03-7bae-95ce-ef51-9cbc0de9b410}">
           <p14:sldIdLst>
             <p14:sldId id="269"/>
             <p14:sldId id="270"/>
@@ -7404,7 +7404,7 @@
                   </a:extLst>
                 </a:hlinkClick>
               </a:rPr>
-              <a:t>https://raw.githack.com/dAAAb/Wanan-AI-Golden-Park-2033/claude/taipei-ai-park-interactive-wsso9d/index.html</a:t>
+              <a:t>https://claude.ai/artifact/8K5y9QidbXzNhXdy4qw3XF</a:t>
             </a:r>
             <a:endParaRPr lang="en-US" sz="1100" dirty="0"/>
           </a:p>

</xml_diff>

<commit_message>
Serve everything from ai2033.taipei
- canonical/og:url/og:image/twitter tags on every page use the new domain;
  robots.txt and sitemap.xml added
- slides/index.html: an on-site slide viewer (16 pages, speaker notes,
  PPTX/PDF downloads) built by tools/build/slides_page.py, which now also
  feeds the Artifact copy; site and transcript link to it
- deck QR code and printed link point at https://ai2033.taipei/
- link verification and e2e run against the new domain; the githack
  interstitial handling is gone

Co-Authored-By: Claude Opus 5.5 <noreply@anthropic.com>
Claude-Session: https://claude.ai/code/session_01UC8CCQNAnYx41QquN8Eiuo
</commit_message>
<xml_diff>
--- a/slides/AI-Golden-Century-Taipei.pptx
+++ b/slides/AI-Golden-Century-Taipei.pptx
@@ -122,19 +122,19 @@
   <p:extLst>
     <p:ext uri="{521415D9-36F7-43E2-AB2F-B90AF26B5E84}">
       <p14:sectionLst xmlns:p14="http://schemas.microsoft.com/office/powerpoint/2010/main">
-        <p14:section name="開場" id="{aad36a92-4567-536f-9810-a32969ca7a51}">
+        <p14:section name="開場" id="{10da2be5-ee70-ef1a-b96f-cff3c1e134f3}">
           <p14:sldIdLst>
             <p14:sldId id="256"/>
           </p14:sldIdLst>
         </p14:section>
-        <p14:section name="願景" id="{ef959c64-0721-e910-bca6-475b7ff2a9f4}">
+        <p14:section name="願景" id="{51a36f00-9baa-7f0d-a79d-b6be31daa148}">
           <p14:sldIdLst>
             <p14:sldId id="257"/>
             <p14:sldId id="258"/>
             <p14:sldId id="259"/>
           </p14:sldIdLst>
         </p14:section>
-        <p14:section name="300公頃" id="{5d6ce175-a6c3-6755-8cdb-0cdacc174c9f}">
+        <p14:section name="300公頃" id="{78eed342-c11e-ef0e-be7f-35f47ccaf473}">
           <p14:sldIdLst>
             <p14:sldId id="260"/>
             <p14:sldId id="261"/>
@@ -143,19 +143,19 @@
             <p14:sldId id="264"/>
           </p14:sldIdLst>
         </p14:section>
-        <p14:section name="交通" id="{8ecfb4a0-56b7-0a76-3f5a-95ed55731658}">
+        <p14:section name="交通" id="{12e414b6-c8f2-8392-d00a-636cf507e7dc}">
           <p14:sldIdLst>
             <p14:sldId id="265"/>
             <p14:sldId id="266"/>
           </p14:sldIdLst>
         </p14:section>
-        <p14:section name="大台北新矽谷" id="{9a188189-4736-2817-f4e9-532448fb3a93}">
+        <p14:section name="大台北新矽谷" id="{e8b79a2e-aa8f-bb6e-8bbf-94deb81425a3}">
           <p14:sldIdLst>
             <p14:sldId id="267"/>
             <p14:sldId id="268"/>
           </p14:sldIdLst>
         </p14:section>
-        <p14:section name="體驗與結語" id="{d77bfd03-7bae-95ce-ef51-9cbc0de9b410}">
+        <p14:section name="體驗與結語" id="{b2c1d162-b261-f20c-b13d-d85ecb54f297}">
           <p14:sldIdLst>
             <p14:sldId id="269"/>
             <p14:sldId id="270"/>
@@ -7404,7 +7404,7 @@
                   </a:extLst>
                 </a:hlinkClick>
               </a:rPr>
-              <a:t>https://claude.ai/artifact/8K5y9QidbXzNhXdy4qw3XF</a:t>
+              <a:t>https://ai2033.taipei/</a:t>
             </a:r>
             <a:endParaRPr lang="en-US" sz="1100" dirty="0"/>
           </a:p>

</xml_diff>